<commit_message>
Convert generalization tables to figures on slide 3
Replace the three generalization tables (cross-domain, temporal, data-scaling)
with matplotlib line charts (scripts/make_figures.py) reading from
data_analysis/analysis_results.json. Each panel plots 4-5 models so the trends
(graceful domain drop, flat temporal lines, monotonic scaling, flat GLM) are
visible at a glance. Updated .pptx and markdown mirror.

Co-Authored-By: Claude Opus 4.7 <noreply@anthropic.com>
</commit_message>
<xml_diff>
--- a/slides/world_model_results.pptx
+++ b/slides/world_model_results.pptx
@@ -4787,1345 +4787,87 @@
           </a:p>
         </p:txBody>
       </p:sp>
-      <p:sp>
-        <p:nvSpPr>
-          <p:cNvPr id="4" name="TextBox 3"/>
-          <p:cNvSpPr txBox="1"/>
+      <p:pic>
+        <p:nvPicPr>
+          <p:cNvPr id="4" name="Picture 3" descr="cross_domain.png"/>
+          <p:cNvPicPr>
+            <a:picLocks noChangeAspect="1"/>
+          </p:cNvPicPr>
           <p:nvPr/>
-        </p:nvSpPr>
+        </p:nvPicPr>
+        <p:blipFill>
+          <a:blip r:embed="rId2"/>
+          <a:stretch>
+            <a:fillRect/>
+          </a:stretch>
+        </p:blipFill>
         <p:spPr>
           <a:xfrm>
-            <a:off x="411480" y="1188720"/>
-            <a:ext cx="3840480" cy="365760"/>
+            <a:off x="164592" y="1234440"/>
+            <a:ext cx="3913632" cy="2888244"/>
           </a:xfrm>
           <a:prstGeom prst="rect">
             <a:avLst/>
           </a:prstGeom>
-          <a:noFill/>
         </p:spPr>
-        <p:txBody>
-          <a:bodyPr wrap="square">
-            <a:spAutoFit/>
-          </a:bodyPr>
-          <a:lstStyle/>
-          <a:p>
-            <a:pPr>
-              <a:spcAft>
-                <a:spcPts val="400"/>
-              </a:spcAft>
-              <a:defRPr sz="1300" b="1">
-                <a:solidFill>
-                  <a:srgbClr val="1F3A5F"/>
-                </a:solidFill>
-                <a:latin typeface="Calibri"/>
-              </a:defRPr>
-            </a:pPr>
-            <a:r>
-              <a:t>Cross-domain (score ρ, train=politics)</a:t>
-            </a:r>
-          </a:p>
-        </p:txBody>
-      </p:sp>
-      <p:graphicFrame>
-        <p:nvGraphicFramePr>
-          <p:cNvPr id="5" name="Table 4"/>
-          <p:cNvGraphicFramePr>
-            <a:graphicFrameLocks noGrp="1"/>
-          </p:cNvGraphicFramePr>
+      </p:pic>
+      <p:pic>
+        <p:nvPicPr>
+          <p:cNvPr id="5" name="Picture 4" descr="temporal.png"/>
+          <p:cNvPicPr>
+            <a:picLocks noChangeAspect="1"/>
+          </p:cNvPicPr>
           <p:nvPr/>
-        </p:nvGraphicFramePr>
-        <p:xfrm>
-          <a:off x="411480" y="1600200"/>
-          <a:ext cx="3840480" cy="2743200"/>
-        </p:xfrm>
-        <a:graphic>
-          <a:graphicData uri="http://schemas.openxmlformats.org/drawingml/2006/table">
-            <a:tbl>
-              <a:tblPr firstRow="1" bandRow="1">
-                <a:tableStyleId>{5C22544A-7EE6-4342-B048-85BDC9FD1C3A}</a:tableStyleId>
-              </a:tblPr>
-              <a:tblGrid>
-                <a:gridCol w="2011680"/>
-                <a:gridCol w="914400"/>
-                <a:gridCol w="914400"/>
-              </a:tblGrid>
-              <a:tr h="457200">
-                <a:tc>
-                  <a:txBody>
-                    <a:bodyPr/>
-                    <a:lstStyle/>
-                    <a:p>
-                      <a:pPr algn="l">
-                        <a:defRPr sz="1200" b="1">
-                          <a:solidFill>
-                            <a:srgbClr val="FFFFFF"/>
-                          </a:solidFill>
-                          <a:latin typeface="Calibri"/>
-                        </a:defRPr>
-                      </a:pPr>
-                      <a:r>
-                        <a:t>test domain</a:t>
-                      </a:r>
-                    </a:p>
-                  </a:txBody>
-                  <a:tcPr marT="12700" marB="12700" marL="63500" marR="63500">
-                    <a:solidFill>
-                      <a:srgbClr val="2E86C1"/>
-                    </a:solidFill>
-                  </a:tcPr>
-                </a:tc>
-                <a:tc>
-                  <a:txBody>
-                    <a:bodyPr/>
-                    <a:lstStyle/>
-                    <a:p>
-                      <a:pPr algn="ctr">
-                        <a:defRPr sz="1200" b="1">
-                          <a:solidFill>
-                            <a:srgbClr val="FFFFFF"/>
-                          </a:solidFill>
-                          <a:latin typeface="Calibri"/>
-                        </a:defRPr>
-                      </a:pPr>
-                      <a:r>
-                        <a:t>qgbm</a:t>
-                      </a:r>
-                    </a:p>
-                  </a:txBody>
-                  <a:tcPr marT="12700" marB="12700" marL="63500" marR="63500">
-                    <a:solidFill>
-                      <a:srgbClr val="2E86C1"/>
-                    </a:solidFill>
-                  </a:tcPr>
-                </a:tc>
-                <a:tc>
-                  <a:txBody>
-                    <a:bodyPr/>
-                    <a:lstStyle/>
-                    <a:p>
-                      <a:pPr algn="ctr">
-                        <a:defRPr sz="1200" b="1">
-                          <a:solidFill>
-                            <a:srgbClr val="FFFFFF"/>
-                          </a:solidFill>
-                          <a:latin typeface="Calibri"/>
-                        </a:defRPr>
-                      </a:pPr>
-                      <a:r>
-                        <a:t>gnn</a:t>
-                      </a:r>
-                    </a:p>
-                  </a:txBody>
-                  <a:tcPr marT="12700" marB="12700" marL="63500" marR="63500">
-                    <a:solidFill>
-                      <a:srgbClr val="2E86C1"/>
-                    </a:solidFill>
-                  </a:tcPr>
-                </a:tc>
-              </a:tr>
-              <a:tr h="457200">
-                <a:tc>
-                  <a:txBody>
-                    <a:bodyPr/>
-                    <a:lstStyle/>
-                    <a:p>
-                      <a:pPr algn="l">
-                        <a:defRPr sz="1100">
-                          <a:latin typeface="Calibri"/>
-                        </a:defRPr>
-                      </a:pPr>
-                      <a:r>
-                        <a:t>politics (in-dom)</a:t>
-                      </a:r>
-                    </a:p>
-                  </a:txBody>
-                  <a:tcPr marT="12700" marB="12700" marL="63500" marR="63500">
-                    <a:solidFill>
-                      <a:srgbClr val="FFFFFF"/>
-                    </a:solidFill>
-                  </a:tcPr>
-                </a:tc>
-                <a:tc>
-                  <a:txBody>
-                    <a:bodyPr/>
-                    <a:lstStyle/>
-                    <a:p>
-                      <a:pPr algn="ctr">
-                        <a:defRPr sz="1100">
-                          <a:latin typeface="Calibri"/>
-                        </a:defRPr>
-                      </a:pPr>
-                      <a:r>
-                        <a:t>0.760</a:t>
-                      </a:r>
-                    </a:p>
-                  </a:txBody>
-                  <a:tcPr marT="12700" marB="12700" marL="63500" marR="63500">
-                    <a:solidFill>
-                      <a:srgbClr val="FFFFFF"/>
-                    </a:solidFill>
-                  </a:tcPr>
-                </a:tc>
-                <a:tc>
-                  <a:txBody>
-                    <a:bodyPr/>
-                    <a:lstStyle/>
-                    <a:p>
-                      <a:pPr algn="ctr">
-                        <a:defRPr sz="1100">
-                          <a:latin typeface="Calibri"/>
-                        </a:defRPr>
-                      </a:pPr>
-                      <a:r>
-                        <a:t>0.746</a:t>
-                      </a:r>
-                    </a:p>
-                  </a:txBody>
-                  <a:tcPr marT="12700" marB="12700" marL="63500" marR="63500">
-                    <a:solidFill>
-                      <a:srgbClr val="FFFFFF"/>
-                    </a:solidFill>
-                  </a:tcPr>
-                </a:tc>
-              </a:tr>
-              <a:tr h="457200">
-                <a:tc>
-                  <a:txBody>
-                    <a:bodyPr/>
-                    <a:lstStyle/>
-                    <a:p>
-                      <a:pPr algn="l">
-                        <a:defRPr sz="1100">
-                          <a:latin typeface="Calibri"/>
-                        </a:defRPr>
-                      </a:pPr>
-                      <a:r>
-                        <a:t>technology</a:t>
-                      </a:r>
-                    </a:p>
-                  </a:txBody>
-                  <a:tcPr marT="12700" marB="12700" marL="63500" marR="63500">
-                    <a:solidFill>
-                      <a:srgbClr val="FFFFFF"/>
-                    </a:solidFill>
-                  </a:tcPr>
-                </a:tc>
-                <a:tc>
-                  <a:txBody>
-                    <a:bodyPr/>
-                    <a:lstStyle/>
-                    <a:p>
-                      <a:pPr algn="ctr">
-                        <a:defRPr sz="1100">
-                          <a:latin typeface="Calibri"/>
-                        </a:defRPr>
-                      </a:pPr>
-                      <a:r>
-                        <a:t>0.737</a:t>
-                      </a:r>
-                    </a:p>
-                  </a:txBody>
-                  <a:tcPr marT="12700" marB="12700" marL="63500" marR="63500">
-                    <a:solidFill>
-                      <a:srgbClr val="FFFFFF"/>
-                    </a:solidFill>
-                  </a:tcPr>
-                </a:tc>
-                <a:tc>
-                  <a:txBody>
-                    <a:bodyPr/>
-                    <a:lstStyle/>
-                    <a:p>
-                      <a:pPr algn="ctr">
-                        <a:defRPr sz="1100">
-                          <a:latin typeface="Calibri"/>
-                        </a:defRPr>
-                      </a:pPr>
-                      <a:r>
-                        <a:t>0.752</a:t>
-                      </a:r>
-                    </a:p>
-                  </a:txBody>
-                  <a:tcPr marT="12700" marB="12700" marL="63500" marR="63500">
-                    <a:solidFill>
-                      <a:srgbClr val="FFFFFF"/>
-                    </a:solidFill>
-                  </a:tcPr>
-                </a:tc>
-              </a:tr>
-              <a:tr h="457200">
-                <a:tc>
-                  <a:txBody>
-                    <a:bodyPr/>
-                    <a:lstStyle/>
-                    <a:p>
-                      <a:pPr algn="l">
-                        <a:defRPr sz="1100">
-                          <a:latin typeface="Calibri"/>
-                        </a:defRPr>
-                      </a:pPr>
-                      <a:r>
-                        <a:t>news</a:t>
-                      </a:r>
-                    </a:p>
-                  </a:txBody>
-                  <a:tcPr marT="12700" marB="12700" marL="63500" marR="63500">
-                    <a:solidFill>
-                      <a:srgbClr val="FFFFFF"/>
-                    </a:solidFill>
-                  </a:tcPr>
-                </a:tc>
-                <a:tc>
-                  <a:txBody>
-                    <a:bodyPr/>
-                    <a:lstStyle/>
-                    <a:p>
-                      <a:pPr algn="ctr">
-                        <a:defRPr sz="1100">
-                          <a:latin typeface="Calibri"/>
-                        </a:defRPr>
-                      </a:pPr>
-                      <a:r>
-                        <a:t>0.723</a:t>
-                      </a:r>
-                    </a:p>
-                  </a:txBody>
-                  <a:tcPr marT="12700" marB="12700" marL="63500" marR="63500">
-                    <a:solidFill>
-                      <a:srgbClr val="FFFFFF"/>
-                    </a:solidFill>
-                  </a:tcPr>
-                </a:tc>
-                <a:tc>
-                  <a:txBody>
-                    <a:bodyPr/>
-                    <a:lstStyle/>
-                    <a:p>
-                      <a:pPr algn="ctr">
-                        <a:defRPr sz="1100">
-                          <a:latin typeface="Calibri"/>
-                        </a:defRPr>
-                      </a:pPr>
-                      <a:r>
-                        <a:t>0.736</a:t>
-                      </a:r>
-                    </a:p>
-                  </a:txBody>
-                  <a:tcPr marT="12700" marB="12700" marL="63500" marR="63500">
-                    <a:solidFill>
-                      <a:srgbClr val="FFFFFF"/>
-                    </a:solidFill>
-                  </a:tcPr>
-                </a:tc>
-              </a:tr>
-              <a:tr h="457200">
-                <a:tc>
-                  <a:txBody>
-                    <a:bodyPr/>
-                    <a:lstStyle/>
-                    <a:p>
-                      <a:pPr algn="l">
-                        <a:defRPr sz="1100">
-                          <a:latin typeface="Calibri"/>
-                        </a:defRPr>
-                      </a:pPr>
-                      <a:r>
-                        <a:t>worldnews</a:t>
-                      </a:r>
-                    </a:p>
-                  </a:txBody>
-                  <a:tcPr marT="12700" marB="12700" marL="63500" marR="63500">
-                    <a:solidFill>
-                      <a:srgbClr val="FFFFFF"/>
-                    </a:solidFill>
-                  </a:tcPr>
-                </a:tc>
-                <a:tc>
-                  <a:txBody>
-                    <a:bodyPr/>
-                    <a:lstStyle/>
-                    <a:p>
-                      <a:pPr algn="ctr">
-                        <a:defRPr sz="1100">
-                          <a:latin typeface="Calibri"/>
-                        </a:defRPr>
-                      </a:pPr>
-                      <a:r>
-                        <a:t>0.685</a:t>
-                      </a:r>
-                    </a:p>
-                  </a:txBody>
-                  <a:tcPr marT="12700" marB="12700" marL="63500" marR="63500">
-                    <a:solidFill>
-                      <a:srgbClr val="FFFFFF"/>
-                    </a:solidFill>
-                  </a:tcPr>
-                </a:tc>
-                <a:tc>
-                  <a:txBody>
-                    <a:bodyPr/>
-                    <a:lstStyle/>
-                    <a:p>
-                      <a:pPr algn="ctr">
-                        <a:defRPr sz="1100">
-                          <a:latin typeface="Calibri"/>
-                        </a:defRPr>
-                      </a:pPr>
-                      <a:r>
-                        <a:t>0.695</a:t>
-                      </a:r>
-                    </a:p>
-                  </a:txBody>
-                  <a:tcPr marT="12700" marB="12700" marL="63500" marR="63500">
-                    <a:solidFill>
-                      <a:srgbClr val="FFFFFF"/>
-                    </a:solidFill>
-                  </a:tcPr>
-                </a:tc>
-              </a:tr>
-              <a:tr h="457200">
-                <a:tc>
-                  <a:txBody>
-                    <a:bodyPr/>
-                    <a:lstStyle/>
-                    <a:p>
-                      <a:pPr algn="l">
-                        <a:defRPr sz="1100">
-                          <a:latin typeface="Calibri"/>
-                        </a:defRPr>
-                      </a:pPr>
-                      <a:r>
-                        <a:t>Conservative</a:t>
-                      </a:r>
-                    </a:p>
-                  </a:txBody>
-                  <a:tcPr marT="12700" marB="12700" marL="63500" marR="63500">
-                    <a:solidFill>
-                      <a:srgbClr val="FFFFFF"/>
-                    </a:solidFill>
-                  </a:tcPr>
-                </a:tc>
-                <a:tc>
-                  <a:txBody>
-                    <a:bodyPr/>
-                    <a:lstStyle/>
-                    <a:p>
-                      <a:pPr algn="ctr">
-                        <a:defRPr sz="1100">
-                          <a:latin typeface="Calibri"/>
-                        </a:defRPr>
-                      </a:pPr>
-                      <a:r>
-                        <a:t>0.670</a:t>
-                      </a:r>
-                    </a:p>
-                  </a:txBody>
-                  <a:tcPr marT="12700" marB="12700" marL="63500" marR="63500">
-                    <a:solidFill>
-                      <a:srgbClr val="FFFFFF"/>
-                    </a:solidFill>
-                  </a:tcPr>
-                </a:tc>
-                <a:tc>
-                  <a:txBody>
-                    <a:bodyPr/>
-                    <a:lstStyle/>
-                    <a:p>
-                      <a:pPr algn="ctr">
-                        <a:defRPr sz="1100">
-                          <a:latin typeface="Calibri"/>
-                        </a:defRPr>
-                      </a:pPr>
-                      <a:r>
-                        <a:t>0.685</a:t>
-                      </a:r>
-                    </a:p>
-                  </a:txBody>
-                  <a:tcPr marT="12700" marB="12700" marL="63500" marR="63500">
-                    <a:solidFill>
-                      <a:srgbClr val="FFFFFF"/>
-                    </a:solidFill>
-                  </a:tcPr>
-                </a:tc>
-              </a:tr>
-            </a:tbl>
-          </a:graphicData>
-        </a:graphic>
-      </p:graphicFrame>
-      <p:sp>
-        <p:nvSpPr>
-          <p:cNvPr id="6" name="TextBox 5"/>
-          <p:cNvSpPr txBox="1"/>
-          <p:nvPr/>
-        </p:nvSpPr>
+        </p:nvPicPr>
+        <p:blipFill>
+          <a:blip r:embed="rId3"/>
+          <a:stretch>
+            <a:fillRect/>
+          </a:stretch>
+        </p:blipFill>
         <p:spPr>
           <a:xfrm>
-            <a:off x="4526280" y="1188720"/>
-            <a:ext cx="3657600" cy="365760"/>
+            <a:off x="4123944" y="1234440"/>
+            <a:ext cx="3913632" cy="2668942"/>
           </a:xfrm>
           <a:prstGeom prst="rect">
             <a:avLst/>
           </a:prstGeom>
-          <a:noFill/>
         </p:spPr>
-        <p:txBody>
-          <a:bodyPr wrap="square">
-            <a:spAutoFit/>
-          </a:bodyPr>
-          <a:lstStyle/>
-          <a:p>
-            <a:pPr>
-              <a:spcAft>
-                <a:spcPts val="400"/>
-              </a:spcAft>
-              <a:defRPr sz="1300" b="1">
-                <a:solidFill>
-                  <a:srgbClr val="1F3A5F"/>
-                </a:solidFill>
-                <a:latin typeface="Calibri"/>
-              </a:defRPr>
-            </a:pPr>
-            <a:r>
-              <a:t>Temporal (politics, score ρ)</a:t>
-            </a:r>
-          </a:p>
-        </p:txBody>
-      </p:sp>
-      <p:graphicFrame>
-        <p:nvGraphicFramePr>
-          <p:cNvPr id="7" name="Table 6"/>
-          <p:cNvGraphicFramePr>
-            <a:graphicFrameLocks noGrp="1"/>
-          </p:cNvGraphicFramePr>
+      </p:pic>
+      <p:pic>
+        <p:nvPicPr>
+          <p:cNvPr id="6" name="Picture 5" descr="data_scaling.png"/>
+          <p:cNvPicPr>
+            <a:picLocks noChangeAspect="1"/>
+          </p:cNvPicPr>
           <p:nvPr/>
-        </p:nvGraphicFramePr>
-        <p:xfrm>
-          <a:off x="4526280" y="1600200"/>
-          <a:ext cx="3657600" cy="2286000"/>
-        </p:xfrm>
-        <a:graphic>
-          <a:graphicData uri="http://schemas.openxmlformats.org/drawingml/2006/table">
-            <a:tbl>
-              <a:tblPr firstRow="1" bandRow="1">
-                <a:tableStyleId>{5C22544A-7EE6-4342-B048-85BDC9FD1C3A}</a:tableStyleId>
-              </a:tblPr>
-              <a:tblGrid>
-                <a:gridCol w="1828800"/>
-                <a:gridCol w="914400"/>
-                <a:gridCol w="914400"/>
-              </a:tblGrid>
-              <a:tr h="457200">
-                <a:tc>
-                  <a:txBody>
-                    <a:bodyPr/>
-                    <a:lstStyle/>
-                    <a:p>
-                      <a:pPr algn="l">
-                        <a:defRPr sz="1200" b="1">
-                          <a:solidFill>
-                            <a:srgbClr val="FFFFFF"/>
-                          </a:solidFill>
-                          <a:latin typeface="Calibri"/>
-                        </a:defRPr>
-                      </a:pPr>
-                      <a:r>
-                        <a:t>train→test gap</a:t>
-                      </a:r>
-                    </a:p>
-                  </a:txBody>
-                  <a:tcPr marT="12700" marB="12700" marL="63500" marR="63500">
-                    <a:solidFill>
-                      <a:srgbClr val="2E86C1"/>
-                    </a:solidFill>
-                  </a:tcPr>
-                </a:tc>
-                <a:tc>
-                  <a:txBody>
-                    <a:bodyPr/>
-                    <a:lstStyle/>
-                    <a:p>
-                      <a:pPr algn="ctr">
-                        <a:defRPr sz="1200" b="1">
-                          <a:solidFill>
-                            <a:srgbClr val="FFFFFF"/>
-                          </a:solidFill>
-                          <a:latin typeface="Calibri"/>
-                        </a:defRPr>
-                      </a:pPr>
-                      <a:r>
-                        <a:t>qgbm</a:t>
-                      </a:r>
-                    </a:p>
-                  </a:txBody>
-                  <a:tcPr marT="12700" marB="12700" marL="63500" marR="63500">
-                    <a:solidFill>
-                      <a:srgbClr val="2E86C1"/>
-                    </a:solidFill>
-                  </a:tcPr>
-                </a:tc>
-                <a:tc>
-                  <a:txBody>
-                    <a:bodyPr/>
-                    <a:lstStyle/>
-                    <a:p>
-                      <a:pPr algn="ctr">
-                        <a:defRPr sz="1200" b="1">
-                          <a:solidFill>
-                            <a:srgbClr val="FFFFFF"/>
-                          </a:solidFill>
-                          <a:latin typeface="Calibri"/>
-                        </a:defRPr>
-                      </a:pPr>
-                      <a:r>
-                        <a:t>feat</a:t>
-                      </a:r>
-                    </a:p>
-                  </a:txBody>
-                  <a:tcPr marT="12700" marB="12700" marL="63500" marR="63500">
-                    <a:solidFill>
-                      <a:srgbClr val="2E86C1"/>
-                    </a:solidFill>
-                  </a:tcPr>
-                </a:tc>
-              </a:tr>
-              <a:tr h="457200">
-                <a:tc>
-                  <a:txBody>
-                    <a:bodyPr/>
-                    <a:lstStyle/>
-                    <a:p>
-                      <a:pPr algn="l">
-                        <a:defRPr sz="1100">
-                          <a:latin typeface="Calibri"/>
-                        </a:defRPr>
-                      </a:pPr>
-                      <a:r>
-                        <a:t>in-domain (0)</a:t>
-                      </a:r>
-                    </a:p>
-                  </a:txBody>
-                  <a:tcPr marT="12700" marB="12700" marL="63500" marR="63500">
-                    <a:solidFill>
-                      <a:srgbClr val="FFFFFF"/>
-                    </a:solidFill>
-                  </a:tcPr>
-                </a:tc>
-                <a:tc>
-                  <a:txBody>
-                    <a:bodyPr/>
-                    <a:lstStyle/>
-                    <a:p>
-                      <a:pPr algn="ctr">
-                        <a:defRPr sz="1100">
-                          <a:latin typeface="Calibri"/>
-                        </a:defRPr>
-                      </a:pPr>
-                      <a:r>
-                        <a:t>0.760</a:t>
-                      </a:r>
-                    </a:p>
-                  </a:txBody>
-                  <a:tcPr marT="12700" marB="12700" marL="63500" marR="63500">
-                    <a:solidFill>
-                      <a:srgbClr val="FFFFFF"/>
-                    </a:solidFill>
-                  </a:tcPr>
-                </a:tc>
-                <a:tc>
-                  <a:txBody>
-                    <a:bodyPr/>
-                    <a:lstStyle/>
-                    <a:p>
-                      <a:pPr algn="ctr">
-                        <a:defRPr sz="1100">
-                          <a:latin typeface="Calibri"/>
-                        </a:defRPr>
-                      </a:pPr>
-                      <a:r>
-                        <a:t>0.759</a:t>
-                      </a:r>
-                    </a:p>
-                  </a:txBody>
-                  <a:tcPr marT="12700" marB="12700" marL="63500" marR="63500">
-                    <a:solidFill>
-                      <a:srgbClr val="FFFFFF"/>
-                    </a:solidFill>
-                  </a:tcPr>
-                </a:tc>
-              </a:tr>
-              <a:tr h="457200">
-                <a:tc>
-                  <a:txBody>
-                    <a:bodyPr/>
-                    <a:lstStyle/>
-                    <a:p>
-                      <a:pPr algn="l">
-                        <a:defRPr sz="1100">
-                          <a:latin typeface="Calibri"/>
-                        </a:defRPr>
-                      </a:pPr>
-                      <a:r>
-                        <a:t>−3 months</a:t>
-                      </a:r>
-                    </a:p>
-                  </a:txBody>
-                  <a:tcPr marT="12700" marB="12700" marL="63500" marR="63500">
-                    <a:solidFill>
-                      <a:srgbClr val="FFFFFF"/>
-                    </a:solidFill>
-                  </a:tcPr>
-                </a:tc>
-                <a:tc>
-                  <a:txBody>
-                    <a:bodyPr/>
-                    <a:lstStyle/>
-                    <a:p>
-                      <a:pPr algn="ctr">
-                        <a:defRPr sz="1100">
-                          <a:latin typeface="Calibri"/>
-                        </a:defRPr>
-                      </a:pPr>
-                      <a:r>
-                        <a:t>0.745</a:t>
-                      </a:r>
-                    </a:p>
-                  </a:txBody>
-                  <a:tcPr marT="12700" marB="12700" marL="63500" marR="63500">
-                    <a:solidFill>
-                      <a:srgbClr val="FFFFFF"/>
-                    </a:solidFill>
-                  </a:tcPr>
-                </a:tc>
-                <a:tc>
-                  <a:txBody>
-                    <a:bodyPr/>
-                    <a:lstStyle/>
-                    <a:p>
-                      <a:pPr algn="ctr">
-                        <a:defRPr sz="1100">
-                          <a:latin typeface="Calibri"/>
-                        </a:defRPr>
-                      </a:pPr>
-                      <a:r>
-                        <a:t>0.750</a:t>
-                      </a:r>
-                    </a:p>
-                  </a:txBody>
-                  <a:tcPr marT="12700" marB="12700" marL="63500" marR="63500">
-                    <a:solidFill>
-                      <a:srgbClr val="FFFFFF"/>
-                    </a:solidFill>
-                  </a:tcPr>
-                </a:tc>
-              </a:tr>
-              <a:tr h="457200">
-                <a:tc>
-                  <a:txBody>
-                    <a:bodyPr/>
-                    <a:lstStyle/>
-                    <a:p>
-                      <a:pPr algn="l">
-                        <a:defRPr sz="1100">
-                          <a:latin typeface="Calibri"/>
-                        </a:defRPr>
-                      </a:pPr>
-                      <a:r>
-                        <a:t>−10 months</a:t>
-                      </a:r>
-                    </a:p>
-                  </a:txBody>
-                  <a:tcPr marT="12700" marB="12700" marL="63500" marR="63500">
-                    <a:solidFill>
-                      <a:srgbClr val="FFFFFF"/>
-                    </a:solidFill>
-                  </a:tcPr>
-                </a:tc>
-                <a:tc>
-                  <a:txBody>
-                    <a:bodyPr/>
-                    <a:lstStyle/>
-                    <a:p>
-                      <a:pPr algn="ctr">
-                        <a:defRPr sz="1100">
-                          <a:latin typeface="Calibri"/>
-                        </a:defRPr>
-                      </a:pPr>
-                      <a:r>
-                        <a:t>0.738</a:t>
-                      </a:r>
-                    </a:p>
-                  </a:txBody>
-                  <a:tcPr marT="12700" marB="12700" marL="63500" marR="63500">
-                    <a:solidFill>
-                      <a:srgbClr val="FFFFFF"/>
-                    </a:solidFill>
-                  </a:tcPr>
-                </a:tc>
-                <a:tc>
-                  <a:txBody>
-                    <a:bodyPr/>
-                    <a:lstStyle/>
-                    <a:p>
-                      <a:pPr algn="ctr">
-                        <a:defRPr sz="1100">
-                          <a:latin typeface="Calibri"/>
-                        </a:defRPr>
-                      </a:pPr>
-                      <a:r>
-                        <a:t>0.741</a:t>
-                      </a:r>
-                    </a:p>
-                  </a:txBody>
-                  <a:tcPr marT="12700" marB="12700" marL="63500" marR="63500">
-                    <a:solidFill>
-                      <a:srgbClr val="FFFFFF"/>
-                    </a:solidFill>
-                  </a:tcPr>
-                </a:tc>
-              </a:tr>
-              <a:tr h="457200">
-                <a:tc>
-                  <a:txBody>
-                    <a:bodyPr/>
-                    <a:lstStyle/>
-                    <a:p>
-                      <a:pPr algn="l">
-                        <a:defRPr sz="1100">
-                          <a:latin typeface="Calibri"/>
-                        </a:defRPr>
-                      </a:pPr>
-                      <a:r>
-                        <a:t>−16 months</a:t>
-                      </a:r>
-                    </a:p>
-                  </a:txBody>
-                  <a:tcPr marT="12700" marB="12700" marL="63500" marR="63500">
-                    <a:solidFill>
-                      <a:srgbClr val="FFFFFF"/>
-                    </a:solidFill>
-                  </a:tcPr>
-                </a:tc>
-                <a:tc>
-                  <a:txBody>
-                    <a:bodyPr/>
-                    <a:lstStyle/>
-                    <a:p>
-                      <a:pPr algn="ctr">
-                        <a:defRPr sz="1100">
-                          <a:latin typeface="Calibri"/>
-                        </a:defRPr>
-                      </a:pPr>
-                      <a:r>
-                        <a:t>0.731</a:t>
-                      </a:r>
-                    </a:p>
-                  </a:txBody>
-                  <a:tcPr marT="12700" marB="12700" marL="63500" marR="63500">
-                    <a:solidFill>
-                      <a:srgbClr val="FFFFFF"/>
-                    </a:solidFill>
-                  </a:tcPr>
-                </a:tc>
-                <a:tc>
-                  <a:txBody>
-                    <a:bodyPr/>
-                    <a:lstStyle/>
-                    <a:p>
-                      <a:pPr algn="ctr">
-                        <a:defRPr sz="1100">
-                          <a:latin typeface="Calibri"/>
-                        </a:defRPr>
-                      </a:pPr>
-                      <a:r>
-                        <a:t>0.736</a:t>
-                      </a:r>
-                    </a:p>
-                  </a:txBody>
-                  <a:tcPr marT="12700" marB="12700" marL="63500" marR="63500">
-                    <a:solidFill>
-                      <a:srgbClr val="FFFFFF"/>
-                    </a:solidFill>
-                  </a:tcPr>
-                </a:tc>
-              </a:tr>
-            </a:tbl>
-          </a:graphicData>
-        </a:graphic>
-      </p:graphicFrame>
-      <p:sp>
-        <p:nvSpPr>
-          <p:cNvPr id="8" name="TextBox 7"/>
-          <p:cNvSpPr txBox="1"/>
-          <p:nvPr/>
-        </p:nvSpPr>
+        </p:nvPicPr>
+        <p:blipFill>
+          <a:blip r:embed="rId4"/>
+          <a:stretch>
+            <a:fillRect/>
+          </a:stretch>
+        </p:blipFill>
         <p:spPr>
           <a:xfrm>
-            <a:off x="8458200" y="1188720"/>
-            <a:ext cx="3474720" cy="365760"/>
+            <a:off x="8083296" y="1234440"/>
+            <a:ext cx="3913632" cy="2668942"/>
           </a:xfrm>
           <a:prstGeom prst="rect">
             <a:avLst/>
           </a:prstGeom>
-          <a:noFill/>
         </p:spPr>
-        <p:txBody>
-          <a:bodyPr wrap="square">
-            <a:spAutoFit/>
-          </a:bodyPr>
-          <a:lstStyle/>
-          <a:p>
-            <a:pPr>
-              <a:spcAft>
-                <a:spcPts val="400"/>
-              </a:spcAft>
-              <a:defRPr sz="1300" b="1">
-                <a:solidFill>
-                  <a:srgbClr val="1F3A5F"/>
-                </a:solidFill>
-                <a:latin typeface="Calibri"/>
-              </a:defRPr>
-            </a:pPr>
-            <a:r>
-              <a:t>Data-scaling (score ρ)</a:t>
-            </a:r>
-          </a:p>
-        </p:txBody>
-      </p:sp>
-      <p:graphicFrame>
-        <p:nvGraphicFramePr>
-          <p:cNvPr id="9" name="Table 8"/>
-          <p:cNvGraphicFramePr>
-            <a:graphicFrameLocks noGrp="1"/>
-          </p:cNvGraphicFramePr>
-          <p:nvPr/>
-        </p:nvGraphicFramePr>
-        <p:xfrm>
-          <a:off x="8458200" y="1600200"/>
-          <a:ext cx="3383280" cy="2743200"/>
-        </p:xfrm>
-        <a:graphic>
-          <a:graphicData uri="http://schemas.openxmlformats.org/drawingml/2006/table">
-            <a:tbl>
-              <a:tblPr firstRow="1" bandRow="1">
-                <a:tableStyleId>{5C22544A-7EE6-4342-B048-85BDC9FD1C3A}</a:tableStyleId>
-              </a:tblPr>
-              <a:tblGrid>
-                <a:gridCol w="1554480"/>
-                <a:gridCol w="914400"/>
-                <a:gridCol w="914400"/>
-              </a:tblGrid>
-              <a:tr h="457200">
-                <a:tc>
-                  <a:txBody>
-                    <a:bodyPr/>
-                    <a:lstStyle/>
-                    <a:p>
-                      <a:pPr algn="l">
-                        <a:defRPr sz="1200" b="1">
-                          <a:solidFill>
-                            <a:srgbClr val="FFFFFF"/>
-                          </a:solidFill>
-                          <a:latin typeface="Calibri"/>
-                        </a:defRPr>
-                      </a:pPr>
-                      <a:r>
-                        <a:t>train n</a:t>
-                      </a:r>
-                    </a:p>
-                  </a:txBody>
-                  <a:tcPr marT="12700" marB="12700" marL="63500" marR="63500">
-                    <a:solidFill>
-                      <a:srgbClr val="2E86C1"/>
-                    </a:solidFill>
-                  </a:tcPr>
-                </a:tc>
-                <a:tc>
-                  <a:txBody>
-                    <a:bodyPr/>
-                    <a:lstStyle/>
-                    <a:p>
-                      <a:pPr algn="ctr">
-                        <a:defRPr sz="1200" b="1">
-                          <a:solidFill>
-                            <a:srgbClr val="FFFFFF"/>
-                          </a:solidFill>
-                          <a:latin typeface="Calibri"/>
-                        </a:defRPr>
-                      </a:pPr>
-                      <a:r>
-                        <a:t>qgbm</a:t>
-                      </a:r>
-                    </a:p>
-                  </a:txBody>
-                  <a:tcPr marT="12700" marB="12700" marL="63500" marR="63500">
-                    <a:solidFill>
-                      <a:srgbClr val="2E86C1"/>
-                    </a:solidFill>
-                  </a:tcPr>
-                </a:tc>
-                <a:tc>
-                  <a:txBody>
-                    <a:bodyPr/>
-                    <a:lstStyle/>
-                    <a:p>
-                      <a:pPr algn="ctr">
-                        <a:defRPr sz="1200" b="1">
-                          <a:solidFill>
-                            <a:srgbClr val="FFFFFF"/>
-                          </a:solidFill>
-                          <a:latin typeface="Calibri"/>
-                        </a:defRPr>
-                      </a:pPr>
-                      <a:r>
-                        <a:t>gnn</a:t>
-                      </a:r>
-                    </a:p>
-                  </a:txBody>
-                  <a:tcPr marT="12700" marB="12700" marL="63500" marR="63500">
-                    <a:solidFill>
-                      <a:srgbClr val="2E86C1"/>
-                    </a:solidFill>
-                  </a:tcPr>
-                </a:tc>
-              </a:tr>
-              <a:tr h="457200">
-                <a:tc>
-                  <a:txBody>
-                    <a:bodyPr/>
-                    <a:lstStyle/>
-                    <a:p>
-                      <a:pPr algn="l">
-                        <a:defRPr sz="1100">
-                          <a:latin typeface="Calibri"/>
-                        </a:defRPr>
-                      </a:pPr>
-                      <a:r>
-                        <a:t>500</a:t>
-                      </a:r>
-                    </a:p>
-                  </a:txBody>
-                  <a:tcPr marT="12700" marB="12700" marL="63500" marR="63500">
-                    <a:solidFill>
-                      <a:srgbClr val="FFFFFF"/>
-                    </a:solidFill>
-                  </a:tcPr>
-                </a:tc>
-                <a:tc>
-                  <a:txBody>
-                    <a:bodyPr/>
-                    <a:lstStyle/>
-                    <a:p>
-                      <a:pPr algn="ctr">
-                        <a:defRPr sz="1100">
-                          <a:latin typeface="Calibri"/>
-                        </a:defRPr>
-                      </a:pPr>
-                      <a:r>
-                        <a:t>0.698</a:t>
-                      </a:r>
-                    </a:p>
-                  </a:txBody>
-                  <a:tcPr marT="12700" marB="12700" marL="63500" marR="63500">
-                    <a:solidFill>
-                      <a:srgbClr val="FFFFFF"/>
-                    </a:solidFill>
-                  </a:tcPr>
-                </a:tc>
-                <a:tc>
-                  <a:txBody>
-                    <a:bodyPr/>
-                    <a:lstStyle/>
-                    <a:p>
-                      <a:pPr algn="ctr">
-                        <a:defRPr sz="1100">
-                          <a:latin typeface="Calibri"/>
-                        </a:defRPr>
-                      </a:pPr>
-                      <a:r>
-                        <a:t>0.710</a:t>
-                      </a:r>
-                    </a:p>
-                  </a:txBody>
-                  <a:tcPr marT="12700" marB="12700" marL="63500" marR="63500">
-                    <a:solidFill>
-                      <a:srgbClr val="FFFFFF"/>
-                    </a:solidFill>
-                  </a:tcPr>
-                </a:tc>
-              </a:tr>
-              <a:tr h="457200">
-                <a:tc>
-                  <a:txBody>
-                    <a:bodyPr/>
-                    <a:lstStyle/>
-                    <a:p>
-                      <a:pPr algn="l">
-                        <a:defRPr sz="1100">
-                          <a:latin typeface="Calibri"/>
-                        </a:defRPr>
-                      </a:pPr>
-                      <a:r>
-                        <a:t>1,000</a:t>
-                      </a:r>
-                    </a:p>
-                  </a:txBody>
-                  <a:tcPr marT="12700" marB="12700" marL="63500" marR="63500">
-                    <a:solidFill>
-                      <a:srgbClr val="FFFFFF"/>
-                    </a:solidFill>
-                  </a:tcPr>
-                </a:tc>
-                <a:tc>
-                  <a:txBody>
-                    <a:bodyPr/>
-                    <a:lstStyle/>
-                    <a:p>
-                      <a:pPr algn="ctr">
-                        <a:defRPr sz="1100">
-                          <a:latin typeface="Calibri"/>
-                        </a:defRPr>
-                      </a:pPr>
-                      <a:r>
-                        <a:t>0.723</a:t>
-                      </a:r>
-                    </a:p>
-                  </a:txBody>
-                  <a:tcPr marT="12700" marB="12700" marL="63500" marR="63500">
-                    <a:solidFill>
-                      <a:srgbClr val="FFFFFF"/>
-                    </a:solidFill>
-                  </a:tcPr>
-                </a:tc>
-                <a:tc>
-                  <a:txBody>
-                    <a:bodyPr/>
-                    <a:lstStyle/>
-                    <a:p>
-                      <a:pPr algn="ctr">
-                        <a:defRPr sz="1100">
-                          <a:latin typeface="Calibri"/>
-                        </a:defRPr>
-                      </a:pPr>
-                      <a:r>
-                        <a:t>0.737</a:t>
-                      </a:r>
-                    </a:p>
-                  </a:txBody>
-                  <a:tcPr marT="12700" marB="12700" marL="63500" marR="63500">
-                    <a:solidFill>
-                      <a:srgbClr val="FFFFFF"/>
-                    </a:solidFill>
-                  </a:tcPr>
-                </a:tc>
-              </a:tr>
-              <a:tr h="457200">
-                <a:tc>
-                  <a:txBody>
-                    <a:bodyPr/>
-                    <a:lstStyle/>
-                    <a:p>
-                      <a:pPr algn="l">
-                        <a:defRPr sz="1100">
-                          <a:latin typeface="Calibri"/>
-                        </a:defRPr>
-                      </a:pPr>
-                      <a:r>
-                        <a:t>2,000</a:t>
-                      </a:r>
-                    </a:p>
-                  </a:txBody>
-                  <a:tcPr marT="12700" marB="12700" marL="63500" marR="63500">
-                    <a:solidFill>
-                      <a:srgbClr val="FFFFFF"/>
-                    </a:solidFill>
-                  </a:tcPr>
-                </a:tc>
-                <a:tc>
-                  <a:txBody>
-                    <a:bodyPr/>
-                    <a:lstStyle/>
-                    <a:p>
-                      <a:pPr algn="ctr">
-                        <a:defRPr sz="1100">
-                          <a:latin typeface="Calibri"/>
-                        </a:defRPr>
-                      </a:pPr>
-                      <a:r>
-                        <a:t>0.731</a:t>
-                      </a:r>
-                    </a:p>
-                  </a:txBody>
-                  <a:tcPr marT="12700" marB="12700" marL="63500" marR="63500">
-                    <a:solidFill>
-                      <a:srgbClr val="FFFFFF"/>
-                    </a:solidFill>
-                  </a:tcPr>
-                </a:tc>
-                <a:tc>
-                  <a:txBody>
-                    <a:bodyPr/>
-                    <a:lstStyle/>
-                    <a:p>
-                      <a:pPr algn="ctr">
-                        <a:defRPr sz="1100">
-                          <a:latin typeface="Calibri"/>
-                        </a:defRPr>
-                      </a:pPr>
-                      <a:r>
-                        <a:t>0.739</a:t>
-                      </a:r>
-                    </a:p>
-                  </a:txBody>
-                  <a:tcPr marT="12700" marB="12700" marL="63500" marR="63500">
-                    <a:solidFill>
-                      <a:srgbClr val="FFFFFF"/>
-                    </a:solidFill>
-                  </a:tcPr>
-                </a:tc>
-              </a:tr>
-              <a:tr h="457200">
-                <a:tc>
-                  <a:txBody>
-                    <a:bodyPr/>
-                    <a:lstStyle/>
-                    <a:p>
-                      <a:pPr algn="l">
-                        <a:defRPr sz="1100">
-                          <a:latin typeface="Calibri"/>
-                        </a:defRPr>
-                      </a:pPr>
-                      <a:r>
-                        <a:t>4,000</a:t>
-                      </a:r>
-                    </a:p>
-                  </a:txBody>
-                  <a:tcPr marT="12700" marB="12700" marL="63500" marR="63500">
-                    <a:solidFill>
-                      <a:srgbClr val="FFFFFF"/>
-                    </a:solidFill>
-                  </a:tcPr>
-                </a:tc>
-                <a:tc>
-                  <a:txBody>
-                    <a:bodyPr/>
-                    <a:lstStyle/>
-                    <a:p>
-                      <a:pPr algn="ctr">
-                        <a:defRPr sz="1100">
-                          <a:latin typeface="Calibri"/>
-                        </a:defRPr>
-                      </a:pPr>
-                      <a:r>
-                        <a:t>0.743</a:t>
-                      </a:r>
-                    </a:p>
-                  </a:txBody>
-                  <a:tcPr marT="12700" marB="12700" marL="63500" marR="63500">
-                    <a:solidFill>
-                      <a:srgbClr val="FFFFFF"/>
-                    </a:solidFill>
-                  </a:tcPr>
-                </a:tc>
-                <a:tc>
-                  <a:txBody>
-                    <a:bodyPr/>
-                    <a:lstStyle/>
-                    <a:p>
-                      <a:pPr algn="ctr">
-                        <a:defRPr sz="1100">
-                          <a:latin typeface="Calibri"/>
-                        </a:defRPr>
-                      </a:pPr>
-                      <a:r>
-                        <a:t>0.740</a:t>
-                      </a:r>
-                    </a:p>
-                  </a:txBody>
-                  <a:tcPr marT="12700" marB="12700" marL="63500" marR="63500">
-                    <a:solidFill>
-                      <a:srgbClr val="FFFFFF"/>
-                    </a:solidFill>
-                  </a:tcPr>
-                </a:tc>
-              </a:tr>
-              <a:tr h="457200">
-                <a:tc>
-                  <a:txBody>
-                    <a:bodyPr/>
-                    <a:lstStyle/>
-                    <a:p>
-                      <a:pPr algn="l">
-                        <a:defRPr sz="1100">
-                          <a:latin typeface="Calibri"/>
-                        </a:defRPr>
-                      </a:pPr>
-                      <a:r>
-                        <a:t>7,596</a:t>
-                      </a:r>
-                    </a:p>
-                  </a:txBody>
-                  <a:tcPr marT="12700" marB="12700" marL="63500" marR="63500">
-                    <a:solidFill>
-                      <a:srgbClr val="FFFFFF"/>
-                    </a:solidFill>
-                  </a:tcPr>
-                </a:tc>
-                <a:tc>
-                  <a:txBody>
-                    <a:bodyPr/>
-                    <a:lstStyle/>
-                    <a:p>
-                      <a:pPr algn="ctr">
-                        <a:defRPr sz="1100">
-                          <a:latin typeface="Calibri"/>
-                        </a:defRPr>
-                      </a:pPr>
-                      <a:r>
-                        <a:t>0.760</a:t>
-                      </a:r>
-                    </a:p>
-                  </a:txBody>
-                  <a:tcPr marT="12700" marB="12700" marL="63500" marR="63500">
-                    <a:solidFill>
-                      <a:srgbClr val="FFFFFF"/>
-                    </a:solidFill>
-                  </a:tcPr>
-                </a:tc>
-                <a:tc>
-                  <a:txBody>
-                    <a:bodyPr/>
-                    <a:lstStyle/>
-                    <a:p>
-                      <a:pPr algn="ctr">
-                        <a:defRPr sz="1100">
-                          <a:latin typeface="Calibri"/>
-                        </a:defRPr>
-                      </a:pPr>
-                      <a:r>
-                        <a:t>0.742</a:t>
-                      </a:r>
-                    </a:p>
-                  </a:txBody>
-                  <a:tcPr marT="12700" marB="12700" marL="63500" marR="63500">
-                    <a:solidFill>
-                      <a:srgbClr val="FFFFFF"/>
-                    </a:solidFill>
-                  </a:tcPr>
-                </a:tc>
-              </a:tr>
-            </a:tbl>
-          </a:graphicData>
-        </a:graphic>
-      </p:graphicFrame>
-      <p:sp>
-        <p:nvSpPr>
-          <p:cNvPr id="10" name="TextBox 9"/>
+      </p:pic>
+      <p:sp>
+        <p:nvSpPr>
+          <p:cNvPr id="7" name="TextBox 6"/>
           <p:cNvSpPr txBox="1"/>
           <p:nvPr/>
         </p:nvSpPr>
         <p:spPr>
           <a:xfrm>
-            <a:off x="411480" y="4617720"/>
+            <a:off x="411480" y="4709160"/>
             <a:ext cx="11521440" cy="2011680"/>
           </a:xfrm>
           <a:prstGeom prst="rect">

</xml_diff>